<commit_message>
Clarify roles and update docs
</commit_message>
<xml_diff>
--- a/Documentation/HotelManagementSystem.pptx
+++ b/Documentation/HotelManagementSystem.pptx
@@ -324,7 +324,7 @@
           <a:p>
             <a:fld id="{5BCAD085-E8A6-8845-BD4E-CB4CCA059FC4}" type="datetimeFigureOut">
               <a:rPr lang="en-US" smtClean="0"/>
-              <a:t>3/9/2026</a:t>
+              <a:t>3/11/2026</a:t>
             </a:fld>
             <a:endParaRPr lang="en-US"/>
           </a:p>
@@ -492,7 +492,7 @@
           <a:p>
             <a:fld id="{5BCAD085-E8A6-8845-BD4E-CB4CCA059FC4}" type="datetimeFigureOut">
               <a:rPr lang="en-US" smtClean="0"/>
-              <a:t>3/9/2026</a:t>
+              <a:t>3/11/2026</a:t>
             </a:fld>
             <a:endParaRPr lang="en-US"/>
           </a:p>
@@ -670,7 +670,7 @@
           <a:p>
             <a:fld id="{5BCAD085-E8A6-8845-BD4E-CB4CCA059FC4}" type="datetimeFigureOut">
               <a:rPr lang="en-US" smtClean="0"/>
-              <a:t>3/9/2026</a:t>
+              <a:t>3/11/2026</a:t>
             </a:fld>
             <a:endParaRPr lang="en-US"/>
           </a:p>
@@ -838,7 +838,7 @@
           <a:p>
             <a:fld id="{5BCAD085-E8A6-8845-BD4E-CB4CCA059FC4}" type="datetimeFigureOut">
               <a:rPr lang="en-US" smtClean="0"/>
-              <a:t>3/9/2026</a:t>
+              <a:t>3/11/2026</a:t>
             </a:fld>
             <a:endParaRPr lang="en-US"/>
           </a:p>
@@ -1083,7 +1083,7 @@
           <a:p>
             <a:fld id="{5BCAD085-E8A6-8845-BD4E-CB4CCA059FC4}" type="datetimeFigureOut">
               <a:rPr lang="en-US" smtClean="0"/>
-              <a:t>3/9/2026</a:t>
+              <a:t>3/11/2026</a:t>
             </a:fld>
             <a:endParaRPr lang="en-US"/>
           </a:p>
@@ -1368,7 +1368,7 @@
           <a:p>
             <a:fld id="{5BCAD085-E8A6-8845-BD4E-CB4CCA059FC4}" type="datetimeFigureOut">
               <a:rPr lang="en-US" smtClean="0"/>
-              <a:t>3/9/2026</a:t>
+              <a:t>3/11/2026</a:t>
             </a:fld>
             <a:endParaRPr lang="en-US"/>
           </a:p>
@@ -1787,7 +1787,7 @@
           <a:p>
             <a:fld id="{5BCAD085-E8A6-8845-BD4E-CB4CCA059FC4}" type="datetimeFigureOut">
               <a:rPr lang="en-US" smtClean="0"/>
-              <a:t>3/9/2026</a:t>
+              <a:t>3/11/2026</a:t>
             </a:fld>
             <a:endParaRPr lang="en-US"/>
           </a:p>
@@ -1904,7 +1904,7 @@
           <a:p>
             <a:fld id="{5BCAD085-E8A6-8845-BD4E-CB4CCA059FC4}" type="datetimeFigureOut">
               <a:rPr lang="en-US" smtClean="0"/>
-              <a:t>3/9/2026</a:t>
+              <a:t>3/11/2026</a:t>
             </a:fld>
             <a:endParaRPr lang="en-US"/>
           </a:p>
@@ -1999,7 +1999,7 @@
           <a:p>
             <a:fld id="{5BCAD085-E8A6-8845-BD4E-CB4CCA059FC4}" type="datetimeFigureOut">
               <a:rPr lang="en-US" smtClean="0"/>
-              <a:t>3/9/2026</a:t>
+              <a:t>3/11/2026</a:t>
             </a:fld>
             <a:endParaRPr lang="en-US"/>
           </a:p>
@@ -2274,7 +2274,7 @@
           <a:p>
             <a:fld id="{5BCAD085-E8A6-8845-BD4E-CB4CCA059FC4}" type="datetimeFigureOut">
               <a:rPr lang="en-US" smtClean="0"/>
-              <a:t>3/9/2026</a:t>
+              <a:t>3/11/2026</a:t>
             </a:fld>
             <a:endParaRPr lang="en-US"/>
           </a:p>
@@ -2526,7 +2526,7 @@
           <a:p>
             <a:fld id="{5BCAD085-E8A6-8845-BD4E-CB4CCA059FC4}" type="datetimeFigureOut">
               <a:rPr lang="en-US" smtClean="0"/>
-              <a:t>3/9/2026</a:t>
+              <a:t>3/11/2026</a:t>
             </a:fld>
             <a:endParaRPr lang="en-US"/>
           </a:p>
@@ -2737,7 +2737,7 @@
           <a:p>
             <a:fld id="{5BCAD085-E8A6-8845-BD4E-CB4CCA059FC4}" type="datetimeFigureOut">
               <a:rPr lang="en-US" smtClean="0"/>
-              <a:t>3/9/2026</a:t>
+              <a:t>3/11/2026</a:t>
             </a:fld>
             <a:endParaRPr lang="en-US"/>
           </a:p>
@@ -3946,7 +3946,25 @@
                 </a:solidFill>
                 <a:latin typeface="Segoe UI"/>
               </a:rPr>
-              <a:t>Success → Receipt Form displayed automatically</a:t>
+              <a:t>Success </a:t>
+            </a:r>
+            <a:r>
+              <a:rPr lang="en-US" sz="2300" dirty="0">
+                <a:solidFill>
+                  <a:srgbClr val="1E2A3A"/>
+                </a:solidFill>
+                <a:latin typeface="Segoe UI"/>
+              </a:rPr>
+              <a:t>-&gt; </a:t>
+            </a:r>
+            <a:r>
+              <a:rPr sz="2300" b="0" dirty="0">
+                <a:solidFill>
+                  <a:srgbClr val="1E2A3A"/>
+                </a:solidFill>
+                <a:latin typeface="Segoe UI"/>
+              </a:rPr>
+              <a:t>Receipt Form displayed automatically</a:t>
             </a:r>
           </a:p>
         </p:txBody>
@@ -4302,7 +4320,7 @@
         <p:spPr>
           <a:xfrm>
             <a:off x="600001" y="1360000"/>
-            <a:ext cx="6153726" cy="3231654"/>
+            <a:ext cx="6153726" cy="2877711"/>
           </a:xfrm>
           <a:prstGeom prst="rect">
             <a:avLst/>
@@ -4323,7 +4341,7 @@
               <a:buChar char="•"/>
             </a:pPr>
             <a:r>
-              <a:rPr sz="2300" b="0" dirty="0">
+              <a:rPr lang="en-US" sz="2300" b="0" dirty="0">
                 <a:solidFill>
                   <a:srgbClr val="1E2A3A"/>
                 </a:solidFill>
@@ -4347,7 +4365,43 @@
                 </a:solidFill>
                 <a:latin typeface="Segoe UI"/>
               </a:rPr>
-              <a:t>Sections:  Guest info  ·  Booking details  ·  Financial breakdown</a:t>
+              <a:t>Sections:  Guest info</a:t>
+            </a:r>
+            <a:r>
+              <a:rPr lang="en-US" sz="2300" b="0" dirty="0">
+                <a:solidFill>
+                  <a:srgbClr val="1E2A3A"/>
+                </a:solidFill>
+                <a:latin typeface="Segoe UI"/>
+              </a:rPr>
+              <a:t>,</a:t>
+            </a:r>
+            <a:r>
+              <a:rPr sz="2300" b="0" dirty="0">
+                <a:solidFill>
+                  <a:srgbClr val="1E2A3A"/>
+                </a:solidFill>
+                <a:latin typeface="Segoe UI"/>
+              </a:rPr>
+              <a:t> Booking details</a:t>
+            </a:r>
+            <a:r>
+              <a:rPr lang="en-US" sz="2300" b="0" dirty="0">
+                <a:solidFill>
+                  <a:srgbClr val="1E2A3A"/>
+                </a:solidFill>
+                <a:latin typeface="Segoe UI"/>
+              </a:rPr>
+              <a:t>,</a:t>
+            </a:r>
+            <a:r>
+              <a:rPr sz="2300" b="0" dirty="0">
+                <a:solidFill>
+                  <a:srgbClr val="1E2A3A"/>
+                </a:solidFill>
+                <a:latin typeface="Segoe UI"/>
+              </a:rPr>
+              <a:t>  Financial breakdown</a:t>
             </a:r>
           </a:p>
           <a:p>
@@ -4383,7 +4437,25 @@
                 </a:solidFill>
                 <a:latin typeface="Segoe UI"/>
               </a:rPr>
-              <a:t>Actions:  Print  ·  Export PDF  ·  Copy to Clipboard</a:t>
+              <a:t>Actions:  Print</a:t>
+            </a:r>
+            <a:r>
+              <a:rPr lang="en-US" sz="2300" b="0" dirty="0">
+                <a:solidFill>
+                  <a:srgbClr val="1E2A3A"/>
+                </a:solidFill>
+                <a:latin typeface="Segoe UI"/>
+              </a:rPr>
+              <a:t>, </a:t>
+            </a:r>
+            <a:r>
+              <a:rPr sz="2300" b="0" dirty="0">
+                <a:solidFill>
+                  <a:srgbClr val="1E2A3A"/>
+                </a:solidFill>
+                <a:latin typeface="Segoe UI"/>
+              </a:rPr>
+              <a:t>Copy to Clipboard</a:t>
             </a:r>
           </a:p>
         </p:txBody>
@@ -4469,10 +4541,10 @@
       </p:sp>
       <p:pic>
         <p:nvPicPr>
-          <p:cNvPr id="10" name="Picture 9">
+          <p:cNvPr id="12" name="Picture 11">
             <a:extLst>
               <a:ext uri="{FF2B5EF4-FFF2-40B4-BE49-F238E27FC236}">
-                <a16:creationId xmlns:a16="http://schemas.microsoft.com/office/drawing/2014/main" id="{F49ACBC1-C012-AFFC-59E0-1935247F1514}"/>
+                <a16:creationId xmlns:a16="http://schemas.microsoft.com/office/drawing/2014/main" id="{436625BE-BCC5-002B-E570-CF305D29220D}"/>
               </a:ext>
             </a:extLst>
           </p:cNvPr>
@@ -4489,8 +4561,8 @@
         </p:blipFill>
         <p:spPr>
           <a:xfrm>
-            <a:off x="7042483" y="1366988"/>
-            <a:ext cx="4722091" cy="4792024"/>
+            <a:off x="7037111" y="1518760"/>
+            <a:ext cx="4467933" cy="4531579"/>
           </a:xfrm>
           <a:prstGeom prst="rect">
             <a:avLst/>
@@ -4739,7 +4811,7 @@
         <p:spPr>
           <a:xfrm>
             <a:off x="600000" y="1360000"/>
-            <a:ext cx="11028825" cy="4948000"/>
+            <a:ext cx="11028825" cy="1815882"/>
           </a:xfrm>
           <a:prstGeom prst="rect">
             <a:avLst/>
@@ -4758,7 +4830,7 @@
               </a:spcBef>
             </a:pPr>
             <a:r>
-              <a:rPr sz="2300" b="0">
+              <a:rPr sz="2300" b="0" dirty="0">
                 <a:solidFill>
                   <a:srgbClr val="1E2A3A"/>
                 </a:solidFill>
@@ -4774,7 +4846,7 @@
               </a:spcBef>
             </a:pPr>
             <a:r>
-              <a:rPr sz="2300" b="0">
+              <a:rPr sz="2300" b="0" dirty="0">
                 <a:solidFill>
                   <a:srgbClr val="1E2A3A"/>
                 </a:solidFill>
@@ -4790,14 +4862,98 @@
               </a:spcBef>
             </a:pPr>
             <a:r>
-              <a:rPr sz="2300" b="0">
-                <a:solidFill>
-                  <a:srgbClr val="1E2A3A"/>
-                </a:solidFill>
-                <a:latin typeface="Segoe UI"/>
-              </a:rPr>
-              <a:t>•   Status tracking:  Pending  ·  Paid  ·  Partially Paid  ·  Cancelled</a:t>
-            </a:r>
+              <a:rPr sz="2300" b="0" dirty="0">
+                <a:solidFill>
+                  <a:srgbClr val="1E2A3A"/>
+                </a:solidFill>
+                <a:latin typeface="Segoe UI"/>
+              </a:rPr>
+              <a:t>•   Status tracking:  Pending</a:t>
+            </a:r>
+            <a:r>
+              <a:rPr lang="en-US" sz="2300" b="0" dirty="0">
+                <a:solidFill>
+                  <a:srgbClr val="1E2A3A"/>
+                </a:solidFill>
+                <a:latin typeface="Segoe UI"/>
+              </a:rPr>
+              <a:t>, </a:t>
+            </a:r>
+            <a:r>
+              <a:rPr sz="2300" b="0" dirty="0">
+                <a:solidFill>
+                  <a:srgbClr val="1E2A3A"/>
+                </a:solidFill>
+                <a:latin typeface="Segoe UI"/>
+              </a:rPr>
+              <a:t>Paid</a:t>
+            </a:r>
+            <a:r>
+              <a:rPr lang="en-US" sz="2300" b="0" dirty="0">
+                <a:solidFill>
+                  <a:srgbClr val="1E2A3A"/>
+                </a:solidFill>
+                <a:latin typeface="Segoe UI"/>
+              </a:rPr>
+              <a:t>, </a:t>
+            </a:r>
+            <a:r>
+              <a:rPr sz="2300" b="0" dirty="0">
+                <a:solidFill>
+                  <a:srgbClr val="1E2A3A"/>
+                </a:solidFill>
+                <a:latin typeface="Segoe UI"/>
+              </a:rPr>
+              <a:t>Partially Paid</a:t>
+            </a:r>
+            <a:r>
+              <a:rPr lang="en-US" sz="2300" b="0" dirty="0">
+                <a:solidFill>
+                  <a:srgbClr val="1E2A3A"/>
+                </a:solidFill>
+                <a:latin typeface="Segoe UI"/>
+              </a:rPr>
+              <a:t>, </a:t>
+            </a:r>
+            <a:r>
+              <a:rPr sz="2300" b="0" dirty="0">
+                <a:solidFill>
+                  <a:srgbClr val="1E2A3A"/>
+                </a:solidFill>
+                <a:latin typeface="Segoe UI"/>
+              </a:rPr>
+              <a:t>Cancelled</a:t>
+            </a:r>
+            <a:endParaRPr lang="en-US" sz="2300" b="0" dirty="0">
+              <a:solidFill>
+                <a:srgbClr val="1E2A3A"/>
+              </a:solidFill>
+              <a:latin typeface="Segoe UI"/>
+            </a:endParaRPr>
+          </a:p>
+          <a:p>
+            <a:pPr marL="342900" indent="-342900">
+              <a:spcBef>
+                <a:spcPts val="800"/>
+              </a:spcBef>
+              <a:buFont typeface="Arial" panose="020B0604020202020204" pitchFamily="34" charset="0"/>
+              <a:buChar char="•"/>
+            </a:pPr>
+            <a:r>
+              <a:rPr lang="en-US" sz="2300" b="0" dirty="0">
+                <a:solidFill>
+                  <a:srgbClr val="1E2A3A"/>
+                </a:solidFill>
+                <a:latin typeface="Segoe UI"/>
+              </a:rPr>
+              <a:t>Process payment after checkout</a:t>
+            </a:r>
+            <a:endParaRPr sz="2300" b="0" dirty="0">
+              <a:solidFill>
+                <a:srgbClr val="1E2A3A"/>
+              </a:solidFill>
+              <a:latin typeface="Segoe UI"/>
+            </a:endParaRPr>
           </a:p>
         </p:txBody>
       </p:sp>
@@ -4882,10 +5038,10 @@
       </p:sp>
       <p:pic>
         <p:nvPicPr>
-          <p:cNvPr id="10" name="Picture 9">
+          <p:cNvPr id="12" name="Picture 11">
             <a:extLst>
               <a:ext uri="{FF2B5EF4-FFF2-40B4-BE49-F238E27FC236}">
-                <a16:creationId xmlns:a16="http://schemas.microsoft.com/office/drawing/2014/main" id="{ECADF6F4-E81A-81B2-8179-B0D86D4A3384}"/>
+                <a16:creationId xmlns:a16="http://schemas.microsoft.com/office/drawing/2014/main" id="{892CF715-6242-29C3-5833-3FA4EE131E53}"/>
               </a:ext>
             </a:extLst>
           </p:cNvPr>
@@ -4902,8 +5058,8 @@
         </p:blipFill>
         <p:spPr>
           <a:xfrm>
-            <a:off x="2944240" y="2708980"/>
-            <a:ext cx="6300343" cy="3347020"/>
+            <a:off x="5312947" y="2826726"/>
+            <a:ext cx="6315877" cy="3394784"/>
           </a:xfrm>
           <a:prstGeom prst="rect">
             <a:avLst/>
@@ -5171,7 +5327,7 @@
               </a:spcBef>
             </a:pPr>
             <a:r>
-              <a:rPr sz="2300" b="0">
+              <a:rPr sz="2300" b="0" dirty="0">
                 <a:solidFill>
                   <a:srgbClr val="1E2A3A"/>
                 </a:solidFill>
@@ -5187,7 +5343,7 @@
               </a:spcBef>
             </a:pPr>
             <a:r>
-              <a:rPr sz="2300" b="0">
+              <a:rPr sz="2300" b="0" dirty="0">
                 <a:solidFill>
                   <a:srgbClr val="1E2A3A"/>
                 </a:solidFill>
@@ -5203,7 +5359,7 @@
               </a:spcBef>
             </a:pPr>
             <a:r>
-              <a:rPr sz="2300" b="0">
+              <a:rPr sz="2300" b="0" dirty="0">
                 <a:solidFill>
                   <a:srgbClr val="1E2A3A"/>
                 </a:solidFill>
@@ -5295,10 +5451,10 @@
       </p:sp>
       <p:pic>
         <p:nvPicPr>
-          <p:cNvPr id="10" name="Picture 9">
+          <p:cNvPr id="12" name="Picture 11">
             <a:extLst>
               <a:ext uri="{FF2B5EF4-FFF2-40B4-BE49-F238E27FC236}">
-                <a16:creationId xmlns:a16="http://schemas.microsoft.com/office/drawing/2014/main" id="{CC1F7B3F-60AF-C4B8-3460-8671DE8269B7}"/>
+                <a16:creationId xmlns:a16="http://schemas.microsoft.com/office/drawing/2014/main" id="{9C5B79F4-92E6-1835-DD34-91834A0E3B34}"/>
               </a:ext>
             </a:extLst>
           </p:cNvPr>
@@ -5315,8 +5471,8 @@
         </p:blipFill>
         <p:spPr>
           <a:xfrm>
-            <a:off x="2953448" y="2718763"/>
-            <a:ext cx="6281928" cy="3337237"/>
+            <a:off x="4942218" y="2731949"/>
+            <a:ext cx="6686607" cy="3594051"/>
           </a:xfrm>
           <a:prstGeom prst="rect">
             <a:avLst/>
@@ -5565,7 +5721,7 @@
         <p:spPr>
           <a:xfrm>
             <a:off x="600000" y="1360000"/>
-            <a:ext cx="11028825" cy="4948000"/>
+            <a:ext cx="11028825" cy="1359346"/>
           </a:xfrm>
           <a:prstGeom prst="rect">
             <a:avLst/>
@@ -5584,7 +5740,7 @@
               </a:spcBef>
             </a:pPr>
             <a:r>
-              <a:rPr sz="2300" b="0">
+              <a:rPr sz="2300" b="0" dirty="0">
                 <a:solidFill>
                   <a:srgbClr val="1E2A3A"/>
                 </a:solidFill>
@@ -5600,14 +5756,65 @@
               </a:spcBef>
             </a:pPr>
             <a:r>
-              <a:rPr sz="2300" b="0">
-                <a:solidFill>
-                  <a:srgbClr val="1E2A3A"/>
-                </a:solidFill>
-                <a:latin typeface="Segoe UI"/>
-              </a:rPr>
-              <a:t>•   Role assignment:  Admin  ·  Receptionist  ·  Housekeeping</a:t>
-            </a:r>
+              <a:rPr sz="2300" b="0" dirty="0">
+                <a:solidFill>
+                  <a:srgbClr val="1E2A3A"/>
+                </a:solidFill>
+                <a:latin typeface="Segoe UI"/>
+              </a:rPr>
+              <a:t>•   Role assignment:  Admin</a:t>
+            </a:r>
+            <a:r>
+              <a:rPr lang="en-US" sz="2300" b="0" dirty="0">
+                <a:solidFill>
+                  <a:srgbClr val="1E2A3A"/>
+                </a:solidFill>
+                <a:latin typeface="Segoe UI"/>
+              </a:rPr>
+              <a:t>,</a:t>
+            </a:r>
+            <a:r>
+              <a:rPr sz="2300" b="0" dirty="0">
+                <a:solidFill>
+                  <a:srgbClr val="1E2A3A"/>
+                </a:solidFill>
+                <a:latin typeface="Segoe UI"/>
+              </a:rPr>
+              <a:t> Receptionist</a:t>
+            </a:r>
+            <a:r>
+              <a:rPr lang="en-US" sz="2300" b="0" dirty="0">
+                <a:solidFill>
+                  <a:srgbClr val="1E2A3A"/>
+                </a:solidFill>
+                <a:latin typeface="Segoe UI"/>
+              </a:rPr>
+              <a:t>, </a:t>
+            </a:r>
+            <a:r>
+              <a:rPr sz="2300" b="0" dirty="0">
+                <a:solidFill>
+                  <a:srgbClr val="1E2A3A"/>
+                </a:solidFill>
+                <a:latin typeface="Segoe UI"/>
+              </a:rPr>
+              <a:t>Housekeeping</a:t>
+            </a:r>
+            <a:r>
+              <a:rPr lang="en-US" sz="2300" b="0" dirty="0">
+                <a:solidFill>
+                  <a:srgbClr val="1E2A3A"/>
+                </a:solidFill>
+                <a:latin typeface="Segoe UI"/>
+              </a:rPr>
+              <a:t>, Manager</a:t>
+            </a:r>
+            <a:endParaRPr sz="2300" b="0" dirty="0">
+              <a:solidFill>
+                <a:srgbClr val="1E2A3A"/>
+              </a:solidFill>
+              <a:latin typeface="Segoe UI"/>
+            </a:endParaRPr>
           </a:p>
           <a:p>
             <a:pPr>
@@ -5616,7 +5823,7 @@
               </a:spcBef>
             </a:pPr>
             <a:r>
-              <a:rPr sz="2300" b="0">
+              <a:rPr sz="2300" b="0" dirty="0">
                 <a:solidFill>
                   <a:srgbClr val="1E2A3A"/>
                 </a:solidFill>
@@ -5708,10 +5915,10 @@
       </p:sp>
       <p:pic>
         <p:nvPicPr>
-          <p:cNvPr id="10" name="Picture 9">
+          <p:cNvPr id="12" name="Picture 11">
             <a:extLst>
               <a:ext uri="{FF2B5EF4-FFF2-40B4-BE49-F238E27FC236}">
-                <a16:creationId xmlns:a16="http://schemas.microsoft.com/office/drawing/2014/main" id="{E34F577B-C396-7983-7666-71F773AB8D66}"/>
+                <a16:creationId xmlns:a16="http://schemas.microsoft.com/office/drawing/2014/main" id="{578462CB-5B0D-DD89-0FD4-1888A21FD766}"/>
               </a:ext>
             </a:extLst>
           </p:cNvPr>
@@ -5728,8 +5935,8 @@
         </p:blipFill>
         <p:spPr>
           <a:xfrm>
-            <a:off x="2949750" y="2714834"/>
-            <a:ext cx="6289324" cy="3341166"/>
+            <a:off x="5270322" y="2719346"/>
+            <a:ext cx="6318503" cy="3396195"/>
           </a:xfrm>
           <a:prstGeom prst="rect">
             <a:avLst/>
@@ -5978,7 +6185,7 @@
         <p:spPr>
           <a:xfrm>
             <a:off x="600000" y="1360000"/>
-            <a:ext cx="11028825" cy="4948000"/>
+            <a:ext cx="11028825" cy="1359346"/>
           </a:xfrm>
           <a:prstGeom prst="rect">
             <a:avLst/>
@@ -5997,7 +6204,7 @@
               </a:spcBef>
             </a:pPr>
             <a:r>
-              <a:rPr sz="2300" b="0">
+              <a:rPr sz="2300" b="0" dirty="0">
                 <a:solidFill>
                   <a:srgbClr val="1E2A3A"/>
                 </a:solidFill>
@@ -6013,7 +6220,7 @@
               </a:spcBef>
             </a:pPr>
             <a:r>
-              <a:rPr sz="2300" b="0">
+              <a:rPr sz="2300" b="0" dirty="0">
                 <a:solidFill>
                   <a:srgbClr val="1E2A3A"/>
                 </a:solidFill>
@@ -6021,6 +6228,36 @@
               </a:rPr>
               <a:t>•   Tracks occupancy, bookings, payments, and outstanding tasks</a:t>
             </a:r>
+            <a:endParaRPr lang="en-US" sz="2300" b="0" dirty="0">
+              <a:solidFill>
+                <a:srgbClr val="1E2A3A"/>
+              </a:solidFill>
+              <a:latin typeface="Segoe UI"/>
+            </a:endParaRPr>
+          </a:p>
+          <a:p>
+            <a:pPr marL="342900" indent="-342900">
+              <a:spcBef>
+                <a:spcPts val="800"/>
+              </a:spcBef>
+              <a:buFont typeface="Arial" panose="020B0604020202020204" pitchFamily="34" charset="0"/>
+              <a:buChar char="•"/>
+            </a:pPr>
+            <a:r>
+              <a:rPr lang="en-US" sz="2300" dirty="0">
+                <a:solidFill>
+                  <a:srgbClr val="1E2A3A"/>
+                </a:solidFill>
+                <a:latin typeface="Segoe UI"/>
+              </a:rPr>
+              <a:t>Export to Excel or PDF</a:t>
+            </a:r>
+            <a:endParaRPr sz="2300" b="0" dirty="0">
+              <a:solidFill>
+                <a:srgbClr val="1E2A3A"/>
+              </a:solidFill>
+              <a:latin typeface="Segoe UI"/>
+            </a:endParaRPr>
           </a:p>
         </p:txBody>
       </p:sp>
@@ -6105,10 +6342,10 @@
       </p:sp>
       <p:pic>
         <p:nvPicPr>
-          <p:cNvPr id="10" name="Picture 9">
+          <p:cNvPr id="12" name="Picture 11">
             <a:extLst>
               <a:ext uri="{FF2B5EF4-FFF2-40B4-BE49-F238E27FC236}">
-                <a16:creationId xmlns:a16="http://schemas.microsoft.com/office/drawing/2014/main" id="{316E48AF-AA3A-8157-4672-8F5BAA2DC54E}"/>
+                <a16:creationId xmlns:a16="http://schemas.microsoft.com/office/drawing/2014/main" id="{FA9C3D4C-7DF8-8076-22BC-599149F116E5}"/>
               </a:ext>
             </a:extLst>
           </p:cNvPr>
@@ -6125,8 +6362,8 @@
         </p:blipFill>
         <p:spPr>
           <a:xfrm>
-            <a:off x="2921444" y="2496855"/>
-            <a:ext cx="6345935" cy="3371240"/>
+            <a:off x="4672583" y="2578520"/>
+            <a:ext cx="6916241" cy="3717480"/>
           </a:xfrm>
           <a:prstGeom prst="rect">
             <a:avLst/>
@@ -6297,7 +6534,7 @@
         <p:spPr>
           <a:xfrm>
             <a:off x="560000" y="430000"/>
-            <a:ext cx="11068825" cy="800000"/>
+            <a:ext cx="11068825" cy="707886"/>
           </a:xfrm>
           <a:prstGeom prst="rect">
             <a:avLst/>
@@ -6311,13 +6548,31 @@
           <a:lstStyle/>
           <a:p>
             <a:r>
-              <a:rPr sz="4000" b="1">
+              <a:rPr sz="4000" b="1" dirty="0">
                 <a:solidFill>
                   <a:srgbClr val="1A235E"/>
                 </a:solidFill>
                 <a:latin typeface="Segoe UI"/>
               </a:rPr>
-              <a:t>Design Patterns — 7 Implemented</a:t>
+              <a:t>Design Patterns — </a:t>
+            </a:r>
+            <a:r>
+              <a:rPr lang="en-US" sz="4000" b="1" dirty="0">
+                <a:solidFill>
+                  <a:srgbClr val="1A235E"/>
+                </a:solidFill>
+                <a:latin typeface="Segoe UI"/>
+              </a:rPr>
+              <a:t>5</a:t>
+            </a:r>
+            <a:r>
+              <a:rPr sz="4000" b="1" dirty="0">
+                <a:solidFill>
+                  <a:srgbClr val="1A235E"/>
+                </a:solidFill>
+                <a:latin typeface="Segoe UI"/>
+              </a:rPr>
+              <a:t> Implemented</a:t>
             </a:r>
           </a:p>
         </p:txBody>
@@ -6375,7 +6630,7 @@
         <p:spPr>
           <a:xfrm>
             <a:off x="600000" y="1360000"/>
-            <a:ext cx="11028825" cy="4948000"/>
+            <a:ext cx="11028825" cy="2118529"/>
           </a:xfrm>
           <a:prstGeom prst="rect">
             <a:avLst/>
@@ -6394,7 +6649,7 @@
               </a:spcBef>
             </a:pPr>
             <a:r>
-              <a:rPr sz="2100" b="0">
+              <a:rPr sz="2100" b="0" dirty="0">
                 <a:solidFill>
                   <a:srgbClr val="1E2A3A"/>
                 </a:solidFill>
@@ -6410,7 +6665,7 @@
               </a:spcBef>
             </a:pPr>
             <a:r>
-              <a:rPr sz="2100" b="0">
+              <a:rPr sz="2100" b="0" dirty="0">
                 <a:solidFill>
                   <a:srgbClr val="1E2A3A"/>
                 </a:solidFill>
@@ -6426,7 +6681,7 @@
               </a:spcBef>
             </a:pPr>
             <a:r>
-              <a:rPr sz="2100" b="0">
+              <a:rPr sz="2100" b="0" dirty="0">
                 <a:solidFill>
                   <a:srgbClr val="1E2A3A"/>
                 </a:solidFill>
@@ -6442,7 +6697,7 @@
               </a:spcBef>
             </a:pPr>
             <a:r>
-              <a:rPr sz="2100" b="0">
+              <a:rPr sz="2100" b="0" dirty="0">
                 <a:solidFill>
                   <a:srgbClr val="1E2A3A"/>
                 </a:solidFill>
@@ -6458,45 +6713,31 @@
               </a:spcBef>
             </a:pPr>
             <a:r>
-              <a:rPr sz="2100" b="0">
-                <a:solidFill>
-                  <a:srgbClr val="1E2A3A"/>
-                </a:solidFill>
-                <a:latin typeface="Segoe UI"/>
-              </a:rPr>
-              <a:t>•   5.  Repository   — clean, centralised data access layer</a:t>
-            </a:r>
-          </a:p>
-          <a:p>
-            <a:pPr>
-              <a:spcBef>
-                <a:spcPts val="800"/>
-              </a:spcBef>
-            </a:pPr>
-            <a:r>
-              <a:rPr sz="2100" b="0">
-                <a:solidFill>
-                  <a:srgbClr val="1E2A3A"/>
-                </a:solidFill>
-                <a:latin typeface="Segoe UI"/>
-              </a:rPr>
-              <a:t>•   6.  Facade       — simplified booking workflow</a:t>
-            </a:r>
-          </a:p>
-          <a:p>
-            <a:pPr>
-              <a:spcBef>
-                <a:spcPts val="800"/>
-              </a:spcBef>
-            </a:pPr>
-            <a:r>
-              <a:rPr sz="2100" b="0">
-                <a:solidFill>
-                  <a:srgbClr val="1E2A3A"/>
-                </a:solidFill>
-                <a:latin typeface="Segoe UI"/>
-              </a:rPr>
-              <a:t>•   7.  Decorator    — stackable room add-on services</a:t>
+              <a:rPr sz="2100" b="0" dirty="0">
+                <a:solidFill>
+                  <a:srgbClr val="1E2A3A"/>
+                </a:solidFill>
+                <a:latin typeface="Segoe UI"/>
+              </a:rPr>
+              <a:t>•   </a:t>
+            </a:r>
+            <a:r>
+              <a:rPr lang="en-US" sz="2100" dirty="0">
+                <a:solidFill>
+                  <a:srgbClr val="1E2A3A"/>
+                </a:solidFill>
+                <a:latin typeface="Segoe UI"/>
+              </a:rPr>
+              <a:t>5</a:t>
+            </a:r>
+            <a:r>
+              <a:rPr sz="2100" b="0" dirty="0">
+                <a:solidFill>
+                  <a:srgbClr val="1E2A3A"/>
+                </a:solidFill>
+                <a:latin typeface="Segoe UI"/>
+              </a:rPr>
+              <a:t>.  Decorator    — stackable room add-on services</a:t>
             </a:r>
           </a:p>
         </p:txBody>
@@ -6871,7 +7112,7 @@
               </a:spcBef>
             </a:pPr>
             <a:r>
-              <a:rPr sz="2300" b="0">
+              <a:rPr sz="2300" b="0" dirty="0">
                 <a:solidFill>
                   <a:srgbClr val="1E2A3A"/>
                 </a:solidFill>
@@ -6887,13 +7128,31 @@
               </a:spcBef>
             </a:pPr>
             <a:r>
-              <a:rPr sz="2300" b="0">
-                <a:solidFill>
-                  <a:srgbClr val="1E2A3A"/>
-                </a:solidFill>
-                <a:latin typeface="Segoe UI"/>
-              </a:rPr>
-              <a:t>•   DatabaseManager — single thread-safe connection pool</a:t>
+              <a:rPr sz="2300" b="0" dirty="0">
+                <a:solidFill>
+                  <a:srgbClr val="1E2A3A"/>
+                </a:solidFill>
+                <a:latin typeface="Segoe UI"/>
+              </a:rPr>
+              <a:t>•   </a:t>
+            </a:r>
+            <a:r>
+              <a:rPr sz="2300" b="0" dirty="0" err="1">
+                <a:solidFill>
+                  <a:srgbClr val="1E2A3A"/>
+                </a:solidFill>
+                <a:latin typeface="Segoe UI"/>
+              </a:rPr>
+              <a:t>DatabaseManager</a:t>
+            </a:r>
+            <a:r>
+              <a:rPr sz="2300" b="0" dirty="0">
+                <a:solidFill>
+                  <a:srgbClr val="1E2A3A"/>
+                </a:solidFill>
+                <a:latin typeface="Segoe UI"/>
+              </a:rPr>
+              <a:t> — single thread-safe connection pool</a:t>
             </a:r>
           </a:p>
           <a:p>
@@ -6903,13 +7162,31 @@
               </a:spcBef>
             </a:pPr>
             <a:r>
-              <a:rPr sz="2300" b="0">
-                <a:solidFill>
-                  <a:srgbClr val="1E2A3A"/>
-                </a:solidFill>
-                <a:latin typeface="Segoe UI"/>
-              </a:rPr>
-              <a:t>•   RoomSubject — one central observable event hub</a:t>
+              <a:rPr sz="2300" b="0" dirty="0">
+                <a:solidFill>
+                  <a:srgbClr val="1E2A3A"/>
+                </a:solidFill>
+                <a:latin typeface="Segoe UI"/>
+              </a:rPr>
+              <a:t>•   </a:t>
+            </a:r>
+            <a:r>
+              <a:rPr sz="2300" b="0" dirty="0" err="1">
+                <a:solidFill>
+                  <a:srgbClr val="1E2A3A"/>
+                </a:solidFill>
+                <a:latin typeface="Segoe UI"/>
+              </a:rPr>
+              <a:t>RoomSubject</a:t>
+            </a:r>
+            <a:r>
+              <a:rPr sz="2300" b="0" dirty="0">
+                <a:solidFill>
+                  <a:srgbClr val="1E2A3A"/>
+                </a:solidFill>
+                <a:latin typeface="Segoe UI"/>
+              </a:rPr>
+              <a:t> — one central observable event hub</a:t>
             </a:r>
           </a:p>
           <a:p>
@@ -6919,7 +7196,7 @@
               </a:spcBef>
             </a:pPr>
             <a:r>
-              <a:rPr sz="2300" b="0">
+              <a:rPr sz="2300" b="0" dirty="0">
                 <a:solidFill>
                   <a:srgbClr val="1E2A3A"/>
                 </a:solidFill>
@@ -7365,7 +7642,61 @@
                 </a:solidFill>
                 <a:latin typeface="Segoe UI"/>
               </a:rPr>
-              <a:t>4 types:  Single  ·  Double  ·  Suite  ·  Deluxe</a:t>
+              <a:t>4 types:  Single</a:t>
+            </a:r>
+            <a:r>
+              <a:rPr lang="en-US" sz="2300" b="0" dirty="0">
+                <a:solidFill>
+                  <a:srgbClr val="1E2A3A"/>
+                </a:solidFill>
+                <a:latin typeface="Segoe UI"/>
+              </a:rPr>
+              <a:t>,</a:t>
+            </a:r>
+            <a:r>
+              <a:rPr sz="2300" b="0" dirty="0">
+                <a:solidFill>
+                  <a:srgbClr val="1E2A3A"/>
+                </a:solidFill>
+                <a:latin typeface="Segoe UI"/>
+              </a:rPr>
+              <a:t>  Double</a:t>
+            </a:r>
+            <a:r>
+              <a:rPr lang="en-US" sz="2300" b="0" dirty="0">
+                <a:solidFill>
+                  <a:srgbClr val="1E2A3A"/>
+                </a:solidFill>
+                <a:latin typeface="Segoe UI"/>
+              </a:rPr>
+              <a:t>,</a:t>
+            </a:r>
+            <a:r>
+              <a:rPr sz="2300" b="0" dirty="0">
+                <a:solidFill>
+                  <a:srgbClr val="1E2A3A"/>
+                </a:solidFill>
+                <a:latin typeface="Segoe UI"/>
+              </a:rPr>
+              <a:t>  Suite</a:t>
+            </a:r>
+            <a:r>
+              <a:rPr lang="en-US" sz="2300" b="0" dirty="0">
+                <a:solidFill>
+                  <a:srgbClr val="1E2A3A"/>
+                </a:solidFill>
+                <a:latin typeface="Segoe UI"/>
+              </a:rPr>
+              <a:t>,</a:t>
+            </a:r>
+            <a:r>
+              <a:rPr sz="2300" b="0" dirty="0">
+                <a:solidFill>
+                  <a:srgbClr val="1E2A3A"/>
+                </a:solidFill>
+                <a:latin typeface="Segoe UI"/>
+              </a:rPr>
+              <a:t> Deluxe</a:t>
             </a:r>
           </a:p>
           <a:p>
@@ -11734,7 +12065,7 @@
         <p:spPr>
           <a:xfrm>
             <a:off x="600000" y="1360000"/>
-            <a:ext cx="11028825" cy="4948000"/>
+            <a:ext cx="11028825" cy="2728952"/>
           </a:xfrm>
           <a:prstGeom prst="rect">
             <a:avLst/>
@@ -11753,7 +12084,7 @@
               </a:spcBef>
             </a:pPr>
             <a:r>
-              <a:rPr sz="2300" b="0">
+              <a:rPr sz="2300" b="0" dirty="0">
                 <a:solidFill>
                   <a:srgbClr val="1E2A3A"/>
                 </a:solidFill>
@@ -11769,7 +12100,7 @@
               </a:spcBef>
             </a:pPr>
             <a:r>
-              <a:rPr sz="2300" b="0">
+              <a:rPr sz="2300" b="0" dirty="0">
                 <a:solidFill>
                   <a:srgbClr val="1E2A3A"/>
                 </a:solidFill>
@@ -11777,6 +12108,54 @@
               </a:rPr>
               <a:t>•   Covers complete lifecycle: booking → check-in → checkout → payment</a:t>
             </a:r>
+            <a:endParaRPr lang="en-US" sz="2300" b="0" dirty="0">
+              <a:solidFill>
+                <a:srgbClr val="1E2A3A"/>
+              </a:solidFill>
+              <a:latin typeface="Segoe UI"/>
+            </a:endParaRPr>
+          </a:p>
+          <a:p>
+            <a:pPr marL="342900" indent="-342900">
+              <a:spcBef>
+                <a:spcPts val="800"/>
+              </a:spcBef>
+              <a:buFont typeface="Arial" panose="020B0604020202020204" pitchFamily="34" charset="0"/>
+              <a:buChar char="•"/>
+            </a:pPr>
+            <a:r>
+              <a:rPr lang="en-US" sz="2300" dirty="0">
+                <a:solidFill>
+                  <a:srgbClr val="1E2A3A"/>
+                </a:solidFill>
+                <a:latin typeface="Segoe UI"/>
+              </a:rPr>
+              <a:t>Staff management</a:t>
+            </a:r>
+          </a:p>
+          <a:p>
+            <a:pPr marL="342900" indent="-342900">
+              <a:spcBef>
+                <a:spcPts val="800"/>
+              </a:spcBef>
+              <a:buFont typeface="Arial" panose="020B0604020202020204" pitchFamily="34" charset="0"/>
+              <a:buChar char="•"/>
+            </a:pPr>
+            <a:r>
+              <a:rPr lang="en-US" sz="2300" b="0" dirty="0">
+                <a:solidFill>
+                  <a:srgbClr val="1E2A3A"/>
+                </a:solidFill>
+                <a:latin typeface="Segoe UI"/>
+              </a:rPr>
+              <a:t>Daily Report</a:t>
+            </a:r>
+            <a:endParaRPr sz="2300" b="0" dirty="0">
+              <a:solidFill>
+                <a:srgbClr val="1E2A3A"/>
+              </a:solidFill>
+              <a:latin typeface="Segoe UI"/>
+            </a:endParaRPr>
           </a:p>
           <a:p>
             <a:pPr>
@@ -11785,14 +12164,65 @@
               </a:spcBef>
             </a:pPr>
             <a:r>
-              <a:rPr sz="2300" b="0">
-                <a:solidFill>
-                  <a:srgbClr val="1E2A3A"/>
-                </a:solidFill>
-                <a:latin typeface="Segoe UI"/>
-              </a:rPr>
-              <a:t>•   Role-based access:  Admin  ·  Receptionist  ·  Housekeeping</a:t>
-            </a:r>
+              <a:rPr sz="2300" b="0" dirty="0">
+                <a:solidFill>
+                  <a:srgbClr val="1E2A3A"/>
+                </a:solidFill>
+                <a:latin typeface="Segoe UI"/>
+              </a:rPr>
+              <a:t>•   Role-based access:  Admin</a:t>
+            </a:r>
+            <a:r>
+              <a:rPr lang="en-US" sz="2300" b="0" dirty="0">
+                <a:solidFill>
+                  <a:srgbClr val="1E2A3A"/>
+                </a:solidFill>
+                <a:latin typeface="Segoe UI"/>
+              </a:rPr>
+              <a:t>,</a:t>
+            </a:r>
+            <a:r>
+              <a:rPr sz="2300" b="0" dirty="0">
+                <a:solidFill>
+                  <a:srgbClr val="1E2A3A"/>
+                </a:solidFill>
+                <a:latin typeface="Segoe UI"/>
+              </a:rPr>
+              <a:t> Receptionist</a:t>
+            </a:r>
+            <a:r>
+              <a:rPr lang="en-US" sz="2300" b="0" dirty="0">
+                <a:solidFill>
+                  <a:srgbClr val="1E2A3A"/>
+                </a:solidFill>
+                <a:latin typeface="Segoe UI"/>
+              </a:rPr>
+              <a:t>,</a:t>
+            </a:r>
+            <a:r>
+              <a:rPr sz="2300" b="0" dirty="0">
+                <a:solidFill>
+                  <a:srgbClr val="1E2A3A"/>
+                </a:solidFill>
+                <a:latin typeface="Segoe UI"/>
+              </a:rPr>
+              <a:t> Housekeeping</a:t>
+            </a:r>
+            <a:r>
+              <a:rPr lang="en-US" sz="2300" b="0" dirty="0">
+                <a:solidFill>
+                  <a:srgbClr val="1E2A3A"/>
+                </a:solidFill>
+                <a:latin typeface="Segoe UI"/>
+              </a:rPr>
+              <a:t>, Manager</a:t>
+            </a:r>
+            <a:endParaRPr sz="2300" b="0" dirty="0">
+              <a:solidFill>
+                <a:srgbClr val="1E2A3A"/>
+              </a:solidFill>
+              <a:latin typeface="Segoe UI"/>
+            </a:endParaRPr>
           </a:p>
           <a:p>
             <a:pPr>
@@ -11801,13 +12231,49 @@
               </a:spcBef>
             </a:pPr>
             <a:r>
-              <a:rPr sz="2300" b="0">
-                <a:solidFill>
-                  <a:srgbClr val="1E2A3A"/>
-                </a:solidFill>
-                <a:latin typeface="Segoe UI"/>
-              </a:rPr>
-              <a:t>•   12 operational forms  ·  Layered architecture  ·  7 design patterns</a:t>
+              <a:rPr sz="2300" b="0" dirty="0">
+                <a:solidFill>
+                  <a:srgbClr val="1E2A3A"/>
+                </a:solidFill>
+                <a:latin typeface="Segoe UI"/>
+              </a:rPr>
+              <a:t>•   12 operational forms</a:t>
+            </a:r>
+            <a:r>
+              <a:rPr lang="en-US" sz="2300" b="0" dirty="0">
+                <a:solidFill>
+                  <a:srgbClr val="1E2A3A"/>
+                </a:solidFill>
+                <a:latin typeface="Segoe UI"/>
+              </a:rPr>
+              <a:t>,</a:t>
+            </a:r>
+            <a:r>
+              <a:rPr sz="2300" b="0" dirty="0">
+                <a:solidFill>
+                  <a:srgbClr val="1E2A3A"/>
+                </a:solidFill>
+                <a:latin typeface="Segoe UI"/>
+              </a:rPr>
+              <a:t> </a:t>
+            </a:r>
+            <a:r>
+              <a:rPr lang="en-US" sz="2300" b="0" dirty="0">
+                <a:solidFill>
+                  <a:srgbClr val="1E2A3A"/>
+                </a:solidFill>
+                <a:latin typeface="Segoe UI"/>
+              </a:rPr>
+              <a:t>5</a:t>
+            </a:r>
+            <a:r>
+              <a:rPr sz="2300" b="0" dirty="0">
+                <a:solidFill>
+                  <a:srgbClr val="1E2A3A"/>
+                </a:solidFill>
+                <a:latin typeface="Segoe UI"/>
+              </a:rPr>
+              <a:t> design patterns</a:t>
             </a:r>
           </a:p>
         </p:txBody>
@@ -11915,6 +12381,36 @@
           </a:p>
         </p:txBody>
       </p:sp>
+      <p:pic>
+        <p:nvPicPr>
+          <p:cNvPr id="11" name="Picture 10">
+            <a:extLst>
+              <a:ext uri="{FF2B5EF4-FFF2-40B4-BE49-F238E27FC236}">
+                <a16:creationId xmlns:a16="http://schemas.microsoft.com/office/drawing/2014/main" id="{F7F7E5B5-79FF-B8F5-4946-1F15F109C5C9}"/>
+              </a:ext>
+            </a:extLst>
+          </p:cNvPr>
+          <p:cNvPicPr>
+            <a:picLocks noChangeAspect="1"/>
+          </p:cNvPicPr>
+          <p:nvPr/>
+        </p:nvPicPr>
+        <p:blipFill>
+          <a:blip r:embed="rId2"/>
+          <a:stretch>
+            <a:fillRect/>
+          </a:stretch>
+        </p:blipFill>
+        <p:spPr>
+          <a:xfrm>
+            <a:off x="6490729" y="3772988"/>
+            <a:ext cx="5098096" cy="2386643"/>
+          </a:xfrm>
+          <a:prstGeom prst="rect">
+            <a:avLst/>
+          </a:prstGeom>
+        </p:spPr>
+      </p:pic>
     </p:spTree>
   </p:cSld>
   <p:clrMapOvr>
@@ -12196,14 +12692,38 @@
               <a:buChar char="•"/>
             </a:pPr>
             <a:r>
+              <a:rPr lang="en-US" sz="2300" dirty="0">
+                <a:solidFill>
+                  <a:srgbClr val="1E2A3A"/>
+                </a:solidFill>
+                <a:latin typeface="Segoe UI"/>
+              </a:rPr>
+              <a:t>Four</a:t>
+            </a:r>
+            <a:r>
               <a:rPr sz="2300" b="0" dirty="0">
                 <a:solidFill>
                   <a:srgbClr val="1E2A3A"/>
                 </a:solidFill>
                 <a:latin typeface="Segoe UI"/>
               </a:rPr>
-              <a:t>Three roles:  Admin  /  Receptionist  /  Housekeeping</a:t>
-            </a:r>
+              <a:t> roles:  Admin  /  Receptionist  /  Housekeeping</a:t>
+            </a:r>
+            <a:r>
+              <a:rPr lang="en-US" sz="2300" b="0" dirty="0">
+                <a:solidFill>
+                  <a:srgbClr val="1E2A3A"/>
+                </a:solidFill>
+                <a:latin typeface="Segoe UI"/>
+              </a:rPr>
+              <a:t>/ Manager</a:t>
+            </a:r>
+            <a:endParaRPr sz="2300" b="0" dirty="0">
+              <a:solidFill>
+                <a:srgbClr val="1E2A3A"/>
+              </a:solidFill>
+              <a:latin typeface="Segoe UI"/>
+            </a:endParaRPr>
           </a:p>
           <a:p>
             <a:pPr marL="342900" indent="-342900">
@@ -12600,7 +13120,7 @@
         <p:spPr>
           <a:xfrm>
             <a:off x="600000" y="1360000"/>
-            <a:ext cx="11028825" cy="4948000"/>
+            <a:ext cx="11028825" cy="1815882"/>
           </a:xfrm>
           <a:prstGeom prst="rect">
             <a:avLst/>
@@ -12641,7 +13161,79 @@
                 </a:solidFill>
                 <a:latin typeface="Segoe UI"/>
               </a:rPr>
-              <a:t>•   Menu bar:  Booking  ·  Guest  ·  Room  ·  Housekeeping  ·  Reports</a:t>
+              <a:t>•   Menu bar:  Booking  </a:t>
+            </a:r>
+            <a:r>
+              <a:rPr lang="en-US" sz="2300" dirty="0">
+                <a:solidFill>
+                  <a:srgbClr val="1E2A3A"/>
+                </a:solidFill>
+                <a:latin typeface="Segoe UI"/>
+              </a:rPr>
+              <a:t>,</a:t>
+            </a:r>
+            <a:r>
+              <a:rPr sz="2300" b="0" dirty="0">
+                <a:solidFill>
+                  <a:srgbClr val="1E2A3A"/>
+                </a:solidFill>
+                <a:latin typeface="Segoe UI"/>
+              </a:rPr>
+              <a:t>Guest  </a:t>
+            </a:r>
+            <a:r>
+              <a:rPr lang="en-US" sz="2300" b="0" dirty="0">
+                <a:solidFill>
+                  <a:srgbClr val="1E2A3A"/>
+                </a:solidFill>
+                <a:latin typeface="Segoe UI"/>
+              </a:rPr>
+              <a:t>,</a:t>
+            </a:r>
+            <a:r>
+              <a:rPr sz="2300" b="0" dirty="0">
+                <a:solidFill>
+                  <a:srgbClr val="1E2A3A"/>
+                </a:solidFill>
+                <a:latin typeface="Segoe UI"/>
+              </a:rPr>
+              <a:t>Room  </a:t>
+            </a:r>
+            <a:r>
+              <a:rPr lang="en-US" sz="2300" b="0" dirty="0">
+                <a:solidFill>
+                  <a:srgbClr val="1E2A3A"/>
+                </a:solidFill>
+                <a:latin typeface="Segoe UI"/>
+              </a:rPr>
+              <a:t>,</a:t>
+            </a:r>
+            <a:r>
+              <a:rPr sz="2300" b="0" dirty="0">
+                <a:solidFill>
+                  <a:srgbClr val="1E2A3A"/>
+                </a:solidFill>
+                <a:latin typeface="Segoe UI"/>
+              </a:rPr>
+              <a:t>Housekeeping</a:t>
+            </a:r>
+            <a:r>
+              <a:rPr lang="en-US" sz="2300" b="0" dirty="0">
+                <a:solidFill>
+                  <a:srgbClr val="1E2A3A"/>
+                </a:solidFill>
+                <a:latin typeface="Segoe UI"/>
+              </a:rPr>
+              <a:t>, </a:t>
+            </a:r>
+            <a:r>
+              <a:rPr sz="2300" b="0" dirty="0">
+                <a:solidFill>
+                  <a:srgbClr val="1E2A3A"/>
+                </a:solidFill>
+                <a:latin typeface="Segoe UI"/>
+              </a:rPr>
+              <a:t>Reports</a:t>
             </a:r>
           </a:p>
           <a:p>
@@ -12759,10 +13351,10 @@
       </p:sp>
       <p:pic>
         <p:nvPicPr>
-          <p:cNvPr id="11" name="Picture 10">
+          <p:cNvPr id="12" name="Picture 11">
             <a:extLst>
               <a:ext uri="{FF2B5EF4-FFF2-40B4-BE49-F238E27FC236}">
-                <a16:creationId xmlns:a16="http://schemas.microsoft.com/office/drawing/2014/main" id="{269757EA-13A6-7753-B63D-82AD82DDF30C}"/>
+                <a16:creationId xmlns:a16="http://schemas.microsoft.com/office/drawing/2014/main" id="{09722867-7012-B360-48CB-5186B5397088}"/>
               </a:ext>
             </a:extLst>
           </p:cNvPr>
@@ -12779,8 +13371,8 @@
         </p:blipFill>
         <p:spPr>
           <a:xfrm>
-            <a:off x="3054681" y="3224463"/>
-            <a:ext cx="5781782" cy="3071537"/>
+            <a:off x="3072385" y="3165720"/>
+            <a:ext cx="5823777" cy="3130280"/>
           </a:xfrm>
           <a:prstGeom prst="rect">
             <a:avLst/>
@@ -13442,7 +14034,7 @@
         <p:spPr>
           <a:xfrm>
             <a:off x="600000" y="1360000"/>
-            <a:ext cx="11028825" cy="2272417"/>
+            <a:ext cx="11028825" cy="1359346"/>
           </a:xfrm>
           <a:prstGeom prst="rect">
             <a:avLst/>
@@ -13467,7 +14059,61 @@
                 </a:solidFill>
                 <a:latin typeface="Segoe UI"/>
               </a:rPr>
-              <a:t>•   Four room types:  Single  ·  Double  ·  Suite  ·  Deluxe</a:t>
+              <a:t>•   Four room types:  Single  </a:t>
+            </a:r>
+            <a:r>
+              <a:rPr lang="en-US" sz="2300" dirty="0">
+                <a:solidFill>
+                  <a:srgbClr val="1E2A3A"/>
+                </a:solidFill>
+                <a:latin typeface="Segoe UI"/>
+              </a:rPr>
+              <a:t>,</a:t>
+            </a:r>
+            <a:r>
+              <a:rPr sz="2300" b="0" dirty="0">
+                <a:solidFill>
+                  <a:srgbClr val="1E2A3A"/>
+                </a:solidFill>
+                <a:latin typeface="Segoe UI"/>
+              </a:rPr>
+              <a:t>Double</a:t>
+            </a:r>
+            <a:r>
+              <a:rPr lang="en-US" sz="2300" b="0" dirty="0">
+                <a:solidFill>
+                  <a:srgbClr val="1E2A3A"/>
+                </a:solidFill>
+                <a:latin typeface="Segoe UI"/>
+              </a:rPr>
+              <a:t>,</a:t>
+            </a:r>
+            <a:r>
+              <a:rPr sz="2300" b="0" dirty="0">
+                <a:solidFill>
+                  <a:srgbClr val="1E2A3A"/>
+                </a:solidFill>
+                <a:latin typeface="Segoe UI"/>
+              </a:rPr>
+              <a:t>  Suite</a:t>
+            </a:r>
+            <a:r>
+              <a:rPr lang="en-US" sz="2300" b="0" dirty="0">
+                <a:solidFill>
+                  <a:srgbClr val="1E2A3A"/>
+                </a:solidFill>
+                <a:latin typeface="Segoe UI"/>
+              </a:rPr>
+              <a:t>,</a:t>
+            </a:r>
+            <a:r>
+              <a:rPr sz="2300" b="0" dirty="0">
+                <a:solidFill>
+                  <a:srgbClr val="1E2A3A"/>
+                </a:solidFill>
+                <a:latin typeface="Segoe UI"/>
+              </a:rPr>
+              <a:t> Deluxe</a:t>
             </a:r>
           </a:p>
           <a:p>
@@ -13483,7 +14129,61 @@
                 </a:solidFill>
                 <a:latin typeface="Segoe UI"/>
               </a:rPr>
-              <a:t>•   Track status:  Available  ·  Occupied  ·  Reserved  ·  Maintenance</a:t>
+              <a:t>•   Track status:  Availabl</a:t>
+            </a:r>
+            <a:r>
+              <a:rPr lang="en-US" sz="2300" b="0" dirty="0">
+                <a:solidFill>
+                  <a:srgbClr val="1E2A3A"/>
+                </a:solidFill>
+                <a:latin typeface="Segoe UI"/>
+              </a:rPr>
+              <a:t>e, </a:t>
+            </a:r>
+            <a:r>
+              <a:rPr sz="2300" b="0" dirty="0">
+                <a:solidFill>
+                  <a:srgbClr val="1E2A3A"/>
+                </a:solidFill>
+                <a:latin typeface="Segoe UI"/>
+              </a:rPr>
+              <a:t>Occupied</a:t>
+            </a:r>
+            <a:r>
+              <a:rPr lang="en-US" sz="2300" b="0" dirty="0">
+                <a:solidFill>
+                  <a:srgbClr val="1E2A3A"/>
+                </a:solidFill>
+                <a:latin typeface="Segoe UI"/>
+              </a:rPr>
+              <a:t>,</a:t>
+            </a:r>
+            <a:r>
+              <a:rPr sz="2300" b="0" dirty="0">
+                <a:solidFill>
+                  <a:srgbClr val="1E2A3A"/>
+                </a:solidFill>
+                <a:latin typeface="Segoe UI"/>
+              </a:rPr>
+              <a:t> Reserved</a:t>
+            </a:r>
+            <a:r>
+              <a:rPr lang="en-US" sz="2300" b="0" dirty="0">
+                <a:solidFill>
+                  <a:srgbClr val="1E2A3A"/>
+                </a:solidFill>
+                <a:latin typeface="Segoe UI"/>
+              </a:rPr>
+              <a:t>,</a:t>
+            </a:r>
+            <a:r>
+              <a:rPr sz="2300" b="0" dirty="0">
+                <a:solidFill>
+                  <a:srgbClr val="1E2A3A"/>
+                </a:solidFill>
+                <a:latin typeface="Segoe UI"/>
+              </a:rPr>
+              <a:t> Maintenance</a:t>
             </a:r>
           </a:p>
           <a:p>
@@ -13499,23 +14199,16 @@
                 </a:solidFill>
                 <a:latin typeface="Segoe UI"/>
               </a:rPr>
-              <a:t>•   Color-coded visual status dashboard</a:t>
-            </a:r>
-          </a:p>
-          <a:p>
-            <a:pPr>
-              <a:spcBef>
-                <a:spcPts val="800"/>
-              </a:spcBef>
-            </a:pPr>
-            <a:r>
-              <a:rPr sz="2300" b="0" dirty="0">
-                <a:solidFill>
-                  <a:srgbClr val="1E2A3A"/>
-                </a:solidFill>
-                <a:latin typeface="Segoe UI"/>
-              </a:rPr>
-              <a:t>•   Room objects created via </a:t>
+              <a:t>•   </a:t>
+            </a:r>
+            <a:r>
+              <a:rPr lang="en-US" sz="2300" dirty="0">
+                <a:solidFill>
+                  <a:srgbClr val="1E2A3A"/>
+                </a:solidFill>
+                <a:latin typeface="Segoe UI"/>
+              </a:rPr>
+              <a:t>Features: Add, edit, update, delete room, search, view detail of room</a:t>
             </a:r>
             <a:endParaRPr lang="en-US" sz="2300" b="0" dirty="0">
               <a:solidFill>
@@ -13524,22 +14217,6 @@
               <a:latin typeface="Segoe UI"/>
             </a:endParaRPr>
           </a:p>
-          <a:p>
-            <a:pPr>
-              <a:spcBef>
-                <a:spcPts val="800"/>
-              </a:spcBef>
-            </a:pPr>
-            <a:r>
-              <a:rPr lang="en-US" sz="2300" b="0" dirty="0">
-                <a:solidFill>
-                  <a:srgbClr val="1E2A3A"/>
-                </a:solidFill>
-                <a:latin typeface="Segoe UI"/>
-              </a:rPr>
-              <a:t>    Factory Pattern</a:t>
-            </a:r>
-          </a:p>
         </p:txBody>
       </p:sp>
       <p:sp>
@@ -13623,10 +14300,10 @@
       </p:sp>
       <p:pic>
         <p:nvPicPr>
-          <p:cNvPr id="10" name="Picture 9">
+          <p:cNvPr id="12" name="Picture 11">
             <a:extLst>
               <a:ext uri="{FF2B5EF4-FFF2-40B4-BE49-F238E27FC236}">
-                <a16:creationId xmlns:a16="http://schemas.microsoft.com/office/drawing/2014/main" id="{6BA100C2-0BDE-2330-7350-613F9AF0FB52}"/>
+                <a16:creationId xmlns:a16="http://schemas.microsoft.com/office/drawing/2014/main" id="{8C80AEF2-6244-7A56-624A-C07B29C4F25F}"/>
               </a:ext>
             </a:extLst>
           </p:cNvPr>
@@ -13643,8 +14320,8 @@
         </p:blipFill>
         <p:spPr>
           <a:xfrm>
-            <a:off x="4931022" y="2963621"/>
-            <a:ext cx="6272784" cy="3332379"/>
+            <a:off x="5166361" y="2853052"/>
+            <a:ext cx="6217920" cy="3342132"/>
           </a:xfrm>
           <a:prstGeom prst="rect">
             <a:avLst/>
@@ -13893,7 +14570,7 @@
         <p:spPr>
           <a:xfrm>
             <a:off x="600000" y="1360000"/>
-            <a:ext cx="11028825" cy="4948000"/>
+            <a:ext cx="11028825" cy="1815882"/>
           </a:xfrm>
           <a:prstGeom prst="rect">
             <a:avLst/>
@@ -13912,7 +14589,7 @@
               </a:spcBef>
             </a:pPr>
             <a:r>
-              <a:rPr sz="2300" b="0">
+              <a:rPr sz="2300" b="0" dirty="0">
                 <a:solidFill>
                   <a:srgbClr val="1E2A3A"/>
                 </a:solidFill>
@@ -13928,14 +14605,101 @@
               </a:spcBef>
             </a:pPr>
             <a:r>
-              <a:rPr sz="2300" b="0">
-                <a:solidFill>
-                  <a:srgbClr val="1E2A3A"/>
-                </a:solidFill>
-                <a:latin typeface="Segoe UI"/>
-              </a:rPr>
-              <a:t>•   Actions:  Check-In  ·  Check-Out  ·  Process Payment  ·  Cancel</a:t>
-            </a:r>
+              <a:rPr sz="2300" b="0" dirty="0">
+                <a:solidFill>
+                  <a:srgbClr val="1E2A3A"/>
+                </a:solidFill>
+                <a:latin typeface="Segoe UI"/>
+              </a:rPr>
+              <a:t>•   Actions:  Check-In  </a:t>
+            </a:r>
+            <a:r>
+              <a:rPr lang="en-US" sz="2300" dirty="0">
+                <a:solidFill>
+                  <a:srgbClr val="1E2A3A"/>
+                </a:solidFill>
+                <a:latin typeface="Segoe UI"/>
+              </a:rPr>
+              <a:t>,</a:t>
+            </a:r>
+            <a:r>
+              <a:rPr sz="2300" b="0" dirty="0">
+                <a:solidFill>
+                  <a:srgbClr val="1E2A3A"/>
+                </a:solidFill>
+                <a:latin typeface="Segoe UI"/>
+              </a:rPr>
+              <a:t>Check-Out</a:t>
+            </a:r>
+            <a:r>
+              <a:rPr lang="en-US" sz="2300" b="0" dirty="0">
+                <a:solidFill>
+                  <a:srgbClr val="1E2A3A"/>
+                </a:solidFill>
+                <a:latin typeface="Segoe UI"/>
+              </a:rPr>
+              <a:t>, </a:t>
+            </a:r>
+            <a:r>
+              <a:rPr sz="2300" b="0" dirty="0">
+                <a:solidFill>
+                  <a:srgbClr val="1E2A3A"/>
+                </a:solidFill>
+                <a:latin typeface="Segoe UI"/>
+              </a:rPr>
+              <a:t>Process Payment</a:t>
+            </a:r>
+            <a:r>
+              <a:rPr lang="en-US" sz="2300" b="0" dirty="0">
+                <a:solidFill>
+                  <a:srgbClr val="1E2A3A"/>
+                </a:solidFill>
+                <a:latin typeface="Segoe UI"/>
+              </a:rPr>
+              <a:t>, </a:t>
+            </a:r>
+            <a:r>
+              <a:rPr sz="2300" b="0" dirty="0">
+                <a:solidFill>
+                  <a:srgbClr val="1E2A3A"/>
+                </a:solidFill>
+                <a:latin typeface="Segoe UI"/>
+              </a:rPr>
+              <a:t>Cancel</a:t>
+            </a:r>
+            <a:r>
+              <a:rPr lang="en-US" sz="2300" b="0" dirty="0">
+                <a:solidFill>
+                  <a:srgbClr val="1E2A3A"/>
+                </a:solidFill>
+                <a:latin typeface="Segoe UI"/>
+              </a:rPr>
+              <a:t>, new booking</a:t>
+            </a:r>
+          </a:p>
+          <a:p>
+            <a:pPr marL="342900" indent="-342900">
+              <a:spcBef>
+                <a:spcPts val="800"/>
+              </a:spcBef>
+              <a:buFont typeface="Arial" panose="020B0604020202020204" pitchFamily="34" charset="0"/>
+              <a:buChar char="•"/>
+            </a:pPr>
+            <a:r>
+              <a:rPr lang="en-US" sz="2300" dirty="0">
+                <a:solidFill>
+                  <a:srgbClr val="1E2A3A"/>
+                </a:solidFill>
+                <a:latin typeface="Segoe UI"/>
+              </a:rPr>
+              <a:t>Search by name or Id</a:t>
+            </a:r>
+            <a:endParaRPr sz="2300" b="0" dirty="0">
+              <a:solidFill>
+                <a:srgbClr val="1E2A3A"/>
+              </a:solidFill>
+              <a:latin typeface="Segoe UI"/>
+            </a:endParaRPr>
           </a:p>
           <a:p>
             <a:pPr>
@@ -13943,15 +14707,12 @@
                 <a:spcPts val="800"/>
               </a:spcBef>
             </a:pPr>
-            <a:r>
-              <a:rPr sz="2300" b="0">
-                <a:solidFill>
-                  <a:srgbClr val="1E2A3A"/>
-                </a:solidFill>
-                <a:latin typeface="Segoe UI"/>
-              </a:rPr>
-              <a:t>•   Check-Out auto-generates invoice + triggers housekeeping task</a:t>
-            </a:r>
+            <a:endParaRPr sz="2300" b="0" dirty="0">
+              <a:solidFill>
+                <a:srgbClr val="1E2A3A"/>
+              </a:solidFill>
+              <a:latin typeface="Segoe UI"/>
+            </a:endParaRPr>
           </a:p>
         </p:txBody>
       </p:sp>
@@ -14036,10 +14797,10 @@
       </p:sp>
       <p:pic>
         <p:nvPicPr>
-          <p:cNvPr id="10" name="Picture 9">
+          <p:cNvPr id="12" name="Picture 11">
             <a:extLst>
               <a:ext uri="{FF2B5EF4-FFF2-40B4-BE49-F238E27FC236}">
-                <a16:creationId xmlns:a16="http://schemas.microsoft.com/office/drawing/2014/main" id="{EA3ED320-F6C6-0303-3311-EB2D5E5B8ADD}"/>
+                <a16:creationId xmlns:a16="http://schemas.microsoft.com/office/drawing/2014/main" id="{41F989DA-6237-3AED-B8B5-F7C90CE3BE64}"/>
               </a:ext>
             </a:extLst>
           </p:cNvPr>
@@ -14056,8 +14817,8 @@
         </p:blipFill>
         <p:spPr>
           <a:xfrm>
-            <a:off x="2941444" y="2924760"/>
-            <a:ext cx="6345935" cy="3371240"/>
+            <a:off x="4681728" y="2628364"/>
+            <a:ext cx="6674435" cy="3587508"/>
           </a:xfrm>
           <a:prstGeom prst="rect">
             <a:avLst/>
@@ -14306,7 +15067,7 @@
         <p:spPr>
           <a:xfrm>
             <a:off x="600001" y="1360000"/>
-            <a:ext cx="5494412" cy="2877711"/>
+            <a:ext cx="5494412" cy="2067233"/>
           </a:xfrm>
           <a:prstGeom prst="rect">
             <a:avLst/>
@@ -14369,17 +15130,17 @@
                 </a:solidFill>
                 <a:latin typeface="Segoe UI"/>
               </a:rPr>
-              <a:t>Add-ons:  Breakfast  ·  Extra Bed  ·  Airport Transfer  (Decorator)</a:t>
-            </a:r>
-          </a:p>
-          <a:p>
-            <a:pPr marL="342900" indent="-342900">
-              <a:spcBef>
-                <a:spcPts val="800"/>
-              </a:spcBef>
-              <a:buFont typeface="Arial" panose="020B0604020202020204" pitchFamily="34" charset="0"/>
-              <a:buChar char="•"/>
-            </a:pPr>
+              <a:t>Add-ons:  Breakfast</a:t>
+            </a:r>
+            <a:r>
+              <a:rPr lang="en-US" sz="2300" b="0" dirty="0">
+                <a:solidFill>
+                  <a:srgbClr val="1E2A3A"/>
+                </a:solidFill>
+                <a:latin typeface="Segoe UI"/>
+              </a:rPr>
+              <a:t>,</a:t>
+            </a:r>
             <a:r>
               <a:rPr sz="2300" b="0" dirty="0">
                 <a:solidFill>
@@ -14387,7 +15148,25 @@
                 </a:solidFill>
                 <a:latin typeface="Segoe UI"/>
               </a:rPr>
-              <a:t>Entire booking workflow managed via Facade Pattern</a:t>
+              <a:t> Extra Bed</a:t>
+            </a:r>
+            <a:r>
+              <a:rPr lang="en-US" sz="2300" b="0" dirty="0">
+                <a:solidFill>
+                  <a:srgbClr val="1E2A3A"/>
+                </a:solidFill>
+                <a:latin typeface="Segoe UI"/>
+              </a:rPr>
+              <a:t>,</a:t>
+            </a:r>
+            <a:r>
+              <a:rPr sz="2300" b="0" dirty="0">
+                <a:solidFill>
+                  <a:srgbClr val="1E2A3A"/>
+                </a:solidFill>
+                <a:latin typeface="Segoe UI"/>
+              </a:rPr>
+              <a:t> Airport Transfer  </a:t>
             </a:r>
           </a:p>
         </p:txBody>
@@ -14497,10 +15276,10 @@
       </p:sp>
       <p:pic>
         <p:nvPicPr>
-          <p:cNvPr id="10" name="Picture 9">
+          <p:cNvPr id="12" name="Picture 11">
             <a:extLst>
               <a:ext uri="{FF2B5EF4-FFF2-40B4-BE49-F238E27FC236}">
-                <a16:creationId xmlns:a16="http://schemas.microsoft.com/office/drawing/2014/main" id="{27106310-5B4A-F84E-A926-2B64CB3B1E7A}"/>
+                <a16:creationId xmlns:a16="http://schemas.microsoft.com/office/drawing/2014/main" id="{CF1FDC63-971D-CA7B-80F1-66A4875B62C0}"/>
               </a:ext>
             </a:extLst>
           </p:cNvPr>
@@ -14517,8 +15296,8 @@
         </p:blipFill>
         <p:spPr>
           <a:xfrm>
-            <a:off x="6325793" y="1384303"/>
-            <a:ext cx="5263031" cy="4941697"/>
+            <a:off x="6402248" y="1435608"/>
+            <a:ext cx="4296231" cy="4776826"/>
           </a:xfrm>
           <a:prstGeom prst="rect">
             <a:avLst/>

</xml_diff>